<commit_message>
Added Preview Mode and New Export Functionality
</commit_message>
<xml_diff>
--- a/ai/src/ppt dataset/Black and White Photographer Portfolio Presentation.pptx
+++ b/ai/src/ppt dataset/Black and White Photographer Portfolio Presentation.pptx
@@ -3269,25 +3269,7 @@
             <a:spAutoFit/>
           </a:bodyPr>
           <a:lstStyle/>
-          <a:p>
-            <a:pPr algn="ctr">
-              <a:lnSpc>
-                <a:spcPts val="8000"/>
-              </a:lnSpc>
-            </a:pPr>
-            <a:r>
-              <a:rPr lang="en-US" b="true" sz="8000" spc="-80">
-                <a:solidFill>
-                  <a:srgbClr val="FFFFFF"/>
-                </a:solidFill>
-                <a:latin typeface="Roboto Condensed Bold"/>
-                <a:ea typeface="Roboto Condensed Bold"/>
-                <a:cs typeface="Roboto Condensed Bold"/>
-                <a:sym typeface="Roboto Condensed Bold"/>
-              </a:rPr>
-              <a:t>PHOTOGRAPHY</a:t>
-            </a:r>
-          </a:p>
+          <a:p/>
         </p:txBody>
       </p:sp>
       <p:sp>
@@ -3310,25 +3292,7 @@
             <a:spAutoFit/>
           </a:bodyPr>
           <a:lstStyle/>
-          <a:p>
-            <a:pPr algn="ctr">
-              <a:lnSpc>
-                <a:spcPts val="6000"/>
-              </a:lnSpc>
-            </a:pPr>
-            <a:r>
-              <a:rPr lang="en-US" b="true" sz="6000" spc="1320">
-                <a:solidFill>
-                  <a:srgbClr val="FFFFFF"/>
-                </a:solidFill>
-                <a:latin typeface="Roboto Condensed Bold"/>
-                <a:ea typeface="Roboto Condensed Bold"/>
-                <a:cs typeface="Roboto Condensed Bold"/>
-                <a:sym typeface="Roboto Condensed Bold"/>
-              </a:rPr>
-              <a:t>PORTFOLIO</a:t>
-            </a:r>
-          </a:p>
+          <a:p/>
         </p:txBody>
       </p:sp>
       <p:sp>
@@ -3351,25 +3315,7 @@
             <a:spAutoFit/>
           </a:bodyPr>
           <a:lstStyle/>
-          <a:p>
-            <a:pPr algn="ctr">
-              <a:lnSpc>
-                <a:spcPts val="3499"/>
-              </a:lnSpc>
-            </a:pPr>
-            <a:r>
-              <a:rPr lang="en-US" sz="2499">
-                <a:solidFill>
-                  <a:srgbClr val="FFFFFF"/>
-                </a:solidFill>
-                <a:latin typeface="Roboto Condensed"/>
-                <a:ea typeface="Roboto Condensed"/>
-                <a:cs typeface="Roboto Condensed"/>
-                <a:sym typeface="Roboto Condensed"/>
-              </a:rPr>
-              <a:t>Chad Gibbons</a:t>
-            </a:r>
-          </a:p>
+          <a:p/>
         </p:txBody>
       </p:sp>
       <p:sp>
@@ -3395,6 +3341,10 @@
             <a:tailEnd type="none" len="sm" w="sm"/>
           </a:ln>
         </p:spPr>
+        <p:txBody>
+          <a:bodyPr/>
+          <a:p/>
+        </p:txBody>
       </p:sp>
       <p:sp>
         <p:nvSpPr>
@@ -3419,6 +3369,10 @@
             <a:tailEnd type="none" len="sm" w="sm"/>
           </a:ln>
         </p:spPr>
+        <p:txBody>
+          <a:bodyPr/>
+          <a:p/>
+        </p:txBody>
       </p:sp>
     </p:spTree>
   </p:cSld>
@@ -3472,28 +3426,7 @@
             <a:spAutoFit/>
           </a:bodyPr>
           <a:lstStyle/>
-          <a:p>
-            <a:pPr algn="ctr">
-              <a:lnSpc>
-                <a:spcPts val="12599"/>
-              </a:lnSpc>
-              <a:spcBef>
-                <a:spcPct val="0"/>
-              </a:spcBef>
-            </a:pPr>
-            <a:r>
-              <a:rPr lang="en-US" b="true" sz="9000" spc="900">
-                <a:solidFill>
-                  <a:srgbClr val="FFFFFF"/>
-                </a:solidFill>
-                <a:latin typeface="Roboto Condensed Bold"/>
-                <a:ea typeface="Roboto Condensed Bold"/>
-                <a:cs typeface="Roboto Condensed Bold"/>
-                <a:sym typeface="Roboto Condensed Bold"/>
-              </a:rPr>
-              <a:t>THANK YOU</a:t>
-            </a:r>
-          </a:p>
+          <a:p/>
         </p:txBody>
       </p:sp>
       <p:sp>
@@ -3516,28 +3449,7 @@
             <a:spAutoFit/>
           </a:bodyPr>
           <a:lstStyle/>
-          <a:p>
-            <a:pPr algn="ctr" marL="0" indent="0" lvl="0">
-              <a:lnSpc>
-                <a:spcPts val="2800"/>
-              </a:lnSpc>
-              <a:spcBef>
-                <a:spcPct val="0"/>
-              </a:spcBef>
-            </a:pPr>
-            <a:r>
-              <a:rPr lang="en-US" sz="2000">
-                <a:solidFill>
-                  <a:srgbClr val="FFFFFF"/>
-                </a:solidFill>
-                <a:latin typeface="Roboto Condensed"/>
-                <a:ea typeface="Roboto Condensed"/>
-                <a:cs typeface="Roboto Condensed"/>
-                <a:sym typeface="Roboto Condensed"/>
-              </a:rPr>
-              <a:t>THAT'S MY PORTFOLIO SO FAR.</a:t>
-            </a:r>
-          </a:p>
+          <a:p/>
         </p:txBody>
       </p:sp>
       <p:sp>
@@ -3563,6 +3475,10 @@
             <a:tailEnd type="none" len="sm" w="sm"/>
           </a:ln>
         </p:spPr>
+        <p:txBody>
+          <a:bodyPr/>
+          <a:p/>
+        </p:txBody>
       </p:sp>
       <p:sp>
         <p:nvSpPr>
@@ -3587,6 +3503,10 @@
             <a:tailEnd type="none" len="sm" w="sm"/>
           </a:ln>
         </p:spPr>
+        <p:txBody>
+          <a:bodyPr/>
+          <a:p/>
+        </p:txBody>
       </p:sp>
     </p:spTree>
   </p:cSld>
@@ -3643,6 +3563,10 @@
             <a:tailEnd type="none" len="sm" w="sm"/>
           </a:ln>
         </p:spPr>
+        <p:txBody>
+          <a:bodyPr/>
+          <a:p/>
+        </p:txBody>
       </p:sp>
       <p:sp>
         <p:nvSpPr>
@@ -3667,6 +3591,10 @@
             <a:tailEnd type="none" len="sm" w="sm"/>
           </a:ln>
         </p:spPr>
+        <p:txBody>
+          <a:bodyPr/>
+          <a:p/>
+        </p:txBody>
       </p:sp>
       <p:grpSp>
         <p:nvGrpSpPr>
@@ -3945,25 +3873,7 @@
             <a:spAutoFit/>
           </a:bodyPr>
           <a:lstStyle/>
-          <a:p>
-            <a:pPr algn="r">
-              <a:lnSpc>
-                <a:spcPts val="2800"/>
-              </a:lnSpc>
-            </a:pPr>
-            <a:r>
-              <a:rPr lang="en-US" sz="2000">
-                <a:solidFill>
-                  <a:srgbClr val="FFFFFF"/>
-                </a:solidFill>
-                <a:latin typeface="Roboto Condensed"/>
-                <a:ea typeface="Roboto Condensed"/>
-                <a:cs typeface="Roboto Condensed"/>
-                <a:sym typeface="Roboto Condensed"/>
-              </a:rPr>
-              <a:t>photography by combining the concept of a building with the technique of taking pictures from the bottom to the top.</a:t>
-            </a:r>
-          </a:p>
+          <a:p/>
         </p:txBody>
       </p:sp>
       <p:sp>
@@ -3986,25 +3896,7 @@
             <a:spAutoFit/>
           </a:bodyPr>
           <a:lstStyle/>
-          <a:p>
-            <a:pPr algn="r">
-              <a:lnSpc>
-                <a:spcPts val="6000"/>
-              </a:lnSpc>
-            </a:pPr>
-            <a:r>
-              <a:rPr lang="en-US" b="true" sz="6000" spc="-60">
-                <a:solidFill>
-                  <a:srgbClr val="FFFFFF"/>
-                </a:solidFill>
-                <a:latin typeface="Roboto Condensed Bold"/>
-                <a:ea typeface="Roboto Condensed Bold"/>
-                <a:cs typeface="Roboto Condensed Bold"/>
-                <a:sym typeface="Roboto Condensed Bold"/>
-              </a:rPr>
-              <a:t>Building Photography</a:t>
-            </a:r>
-          </a:p>
+          <a:p/>
         </p:txBody>
       </p:sp>
       <p:grpSp>
@@ -4070,6 +3962,10 @@
             <a:tailEnd type="none" len="sm" w="sm"/>
           </a:ln>
         </p:spPr>
+        <p:txBody>
+          <a:bodyPr/>
+          <a:p/>
+        </p:txBody>
       </p:sp>
       <p:sp>
         <p:nvSpPr>
@@ -4094,6 +3990,10 @@
             <a:tailEnd type="none" len="sm" w="sm"/>
           </a:ln>
         </p:spPr>
+        <p:txBody>
+          <a:bodyPr/>
+          <a:p/>
+        </p:txBody>
       </p:sp>
     </p:spTree>
   </p:cSld>
@@ -4147,25 +4047,7 @@
             <a:spAutoFit/>
           </a:bodyPr>
           <a:lstStyle/>
-          <a:p>
-            <a:pPr algn="l">
-              <a:lnSpc>
-                <a:spcPts val="2800"/>
-              </a:lnSpc>
-            </a:pPr>
-            <a:r>
-              <a:rPr lang="en-US" sz="2000">
-                <a:solidFill>
-                  <a:srgbClr val="FFFFFF"/>
-                </a:solidFill>
-                <a:latin typeface="Roboto Condensed"/>
-                <a:ea typeface="Roboto Condensed"/>
-                <a:cs typeface="Roboto Condensed"/>
-                <a:sym typeface="Roboto Condensed"/>
-              </a:rPr>
-              <a:t>photography by combining the concept of a building with the technique of taking pictures from the bottom to the top.</a:t>
-            </a:r>
-          </a:p>
+          <a:p/>
         </p:txBody>
       </p:sp>
       <p:sp>
@@ -4188,25 +4070,7 @@
             <a:spAutoFit/>
           </a:bodyPr>
           <a:lstStyle/>
-          <a:p>
-            <a:pPr algn="l">
-              <a:lnSpc>
-                <a:spcPts val="6000"/>
-              </a:lnSpc>
-            </a:pPr>
-            <a:r>
-              <a:rPr lang="en-US" sz="6000" spc="-60" b="true">
-                <a:solidFill>
-                  <a:srgbClr val="FFFFFF"/>
-                </a:solidFill>
-                <a:latin typeface="Roboto Condensed Bold"/>
-                <a:ea typeface="Roboto Condensed Bold"/>
-                <a:cs typeface="Roboto Condensed Bold"/>
-                <a:sym typeface="Roboto Condensed Bold"/>
-              </a:rPr>
-              <a:t>Building Photography</a:t>
-            </a:r>
-          </a:p>
+          <a:p/>
         </p:txBody>
       </p:sp>
       <p:grpSp>
@@ -4352,6 +4216,10 @@
             <a:tailEnd type="none" len="sm" w="sm"/>
           </a:ln>
         </p:spPr>
+        <p:txBody>
+          <a:bodyPr/>
+          <a:p/>
+        </p:txBody>
       </p:sp>
       <p:sp>
         <p:nvSpPr>
@@ -4376,6 +4244,10 @@
             <a:tailEnd type="none" len="sm" w="sm"/>
           </a:ln>
         </p:spPr>
+        <p:txBody>
+          <a:bodyPr/>
+          <a:p/>
+        </p:txBody>
       </p:sp>
     </p:spTree>
   </p:cSld>
@@ -4432,6 +4304,10 @@
             <a:tailEnd type="none" len="sm" w="sm"/>
           </a:ln>
         </p:spPr>
+        <p:txBody>
+          <a:bodyPr/>
+          <a:p/>
+        </p:txBody>
       </p:sp>
       <p:sp>
         <p:nvSpPr>
@@ -4456,6 +4332,10 @@
             <a:tailEnd type="none" len="sm" w="sm"/>
           </a:ln>
         </p:spPr>
+        <p:txBody>
+          <a:bodyPr/>
+          <a:p/>
+        </p:txBody>
       </p:sp>
       <p:sp>
         <p:nvSpPr>
@@ -4477,25 +4357,7 @@
             <a:spAutoFit/>
           </a:bodyPr>
           <a:lstStyle/>
-          <a:p>
-            <a:pPr algn="l">
-              <a:lnSpc>
-                <a:spcPts val="6000"/>
-              </a:lnSpc>
-            </a:pPr>
-            <a:r>
-              <a:rPr lang="en-US" sz="6000" b="true">
-                <a:solidFill>
-                  <a:srgbClr val="FFFFFF"/>
-                </a:solidFill>
-                <a:latin typeface="Roboto Condensed Bold"/>
-                <a:ea typeface="Roboto Condensed Bold"/>
-                <a:cs typeface="Roboto Condensed Bold"/>
-                <a:sym typeface="Roboto Condensed Bold"/>
-              </a:rPr>
-              <a:t>Work Experience</a:t>
-            </a:r>
-          </a:p>
+          <a:p/>
         </p:txBody>
       </p:sp>
       <p:grpSp>
@@ -4824,6 +4686,10 @@
             <a:tailEnd type="none" len="sm" w="sm"/>
           </a:ln>
         </p:spPr>
+        <p:txBody>
+          <a:bodyPr/>
+          <a:p/>
+        </p:txBody>
       </p:sp>
       <p:sp>
         <p:nvSpPr>
@@ -4848,6 +4714,10 @@
             <a:tailEnd type="none" len="sm" w="sm"/>
           </a:ln>
         </p:spPr>
+        <p:txBody>
+          <a:bodyPr/>
+          <a:p/>
+        </p:txBody>
       </p:sp>
       <p:grpSp>
         <p:nvGrpSpPr>
@@ -5109,25 +4979,7 @@
             <a:spAutoFit/>
           </a:bodyPr>
           <a:lstStyle/>
-          <a:p>
-            <a:pPr algn="l">
-              <a:lnSpc>
-                <a:spcPts val="6000"/>
-              </a:lnSpc>
-            </a:pPr>
-            <a:r>
-              <a:rPr lang="en-US" sz="6000" spc="-60" b="true">
-                <a:solidFill>
-                  <a:srgbClr val="FFFFFF"/>
-                </a:solidFill>
-                <a:latin typeface="Roboto Condensed Bold"/>
-                <a:ea typeface="Roboto Condensed Bold"/>
-                <a:cs typeface="Roboto Condensed Bold"/>
-                <a:sym typeface="Roboto Condensed Bold"/>
-              </a:rPr>
-              <a:t>Portfolio</a:t>
-            </a:r>
-          </a:p>
+          <a:p/>
         </p:txBody>
       </p:sp>
     </p:spTree>
@@ -5182,25 +5034,7 @@
             <a:spAutoFit/>
           </a:bodyPr>
           <a:lstStyle/>
-          <a:p>
-            <a:pPr algn="l">
-              <a:lnSpc>
-                <a:spcPts val="6000"/>
-              </a:lnSpc>
-            </a:pPr>
-            <a:r>
-              <a:rPr lang="en-US" sz="6000" spc="-60" b="true">
-                <a:solidFill>
-                  <a:srgbClr val="FFFFFF"/>
-                </a:solidFill>
-                <a:latin typeface="Roboto Condensed Bold"/>
-                <a:ea typeface="Roboto Condensed Bold"/>
-                <a:cs typeface="Roboto Condensed Bold"/>
-                <a:sym typeface="Roboto Condensed Bold"/>
-              </a:rPr>
-              <a:t>Street Photography</a:t>
-            </a:r>
-          </a:p>
+          <a:p/>
         </p:txBody>
       </p:sp>
       <p:grpSp>
@@ -5306,6 +5140,10 @@
             <a:tailEnd type="none" len="sm" w="sm"/>
           </a:ln>
         </p:spPr>
+        <p:txBody>
+          <a:bodyPr/>
+          <a:p/>
+        </p:txBody>
       </p:sp>
       <p:sp>
         <p:nvSpPr>
@@ -5330,6 +5168,10 @@
             <a:tailEnd type="none" len="sm" w="sm"/>
           </a:ln>
         </p:spPr>
+        <p:txBody>
+          <a:bodyPr/>
+          <a:p/>
+        </p:txBody>
       </p:sp>
       <p:sp>
         <p:nvSpPr>
@@ -5351,25 +5193,7 @@
             <a:spAutoFit/>
           </a:bodyPr>
           <a:lstStyle/>
-          <a:p>
-            <a:pPr algn="l">
-              <a:lnSpc>
-                <a:spcPts val="2800"/>
-              </a:lnSpc>
-            </a:pPr>
-            <a:r>
-              <a:rPr lang="en-US" sz="2000">
-                <a:solidFill>
-                  <a:srgbClr val="FFFFFF"/>
-                </a:solidFill>
-                <a:latin typeface="Roboto Condensed"/>
-                <a:ea typeface="Roboto Condensed"/>
-                <a:cs typeface="Roboto Condensed"/>
-                <a:sym typeface="Roboto Condensed"/>
-              </a:rPr>
-              <a:t>photography by combining the concept of a street with the technique of taking pictures from the top.</a:t>
-            </a:r>
-          </a:p>
+          <a:p/>
         </p:txBody>
       </p:sp>
     </p:spTree>
@@ -5464,25 +5288,7 @@
             <a:spAutoFit/>
           </a:bodyPr>
           <a:lstStyle/>
-          <a:p>
-            <a:pPr algn="r">
-              <a:lnSpc>
-                <a:spcPts val="6000"/>
-              </a:lnSpc>
-            </a:pPr>
-            <a:r>
-              <a:rPr lang="en-US" b="true" sz="6000" spc="-60">
-                <a:solidFill>
-                  <a:srgbClr val="FFFFFF"/>
-                </a:solidFill>
-                <a:latin typeface="Roboto Condensed Bold"/>
-                <a:ea typeface="Roboto Condensed Bold"/>
-                <a:cs typeface="Roboto Condensed Bold"/>
-                <a:sym typeface="Roboto Condensed Bold"/>
-              </a:rPr>
-              <a:t>Street Photography</a:t>
-            </a:r>
-          </a:p>
+          <a:p/>
         </p:txBody>
       </p:sp>
       <p:sp>
@@ -5505,25 +5311,7 @@
             <a:spAutoFit/>
           </a:bodyPr>
           <a:lstStyle/>
-          <a:p>
-            <a:pPr algn="r">
-              <a:lnSpc>
-                <a:spcPts val="2800"/>
-              </a:lnSpc>
-            </a:pPr>
-            <a:r>
-              <a:rPr lang="en-US" sz="2000">
-                <a:solidFill>
-                  <a:srgbClr val="FFFFFF"/>
-                </a:solidFill>
-                <a:latin typeface="Roboto Condensed"/>
-                <a:ea typeface="Roboto Condensed"/>
-                <a:cs typeface="Roboto Condensed"/>
-                <a:sym typeface="Roboto Condensed"/>
-              </a:rPr>
-              <a:t>photography by combining the concept of a street with the technique of taking pictures from the top.</a:t>
-            </a:r>
-          </a:p>
+          <a:p/>
         </p:txBody>
       </p:sp>
       <p:sp>
@@ -5549,6 +5337,10 @@
             <a:tailEnd type="none" len="sm" w="sm"/>
           </a:ln>
         </p:spPr>
+        <p:txBody>
+          <a:bodyPr/>
+          <a:p/>
+        </p:txBody>
       </p:sp>
       <p:sp>
         <p:nvSpPr>
@@ -5573,6 +5365,10 @@
             <a:tailEnd type="none" len="sm" w="sm"/>
           </a:ln>
         </p:spPr>
+        <p:txBody>
+          <a:bodyPr/>
+          <a:p/>
+        </p:txBody>
       </p:sp>
     </p:spTree>
   </p:cSld>
@@ -5708,25 +5504,7 @@
             <a:spAutoFit/>
           </a:bodyPr>
           <a:lstStyle/>
-          <a:p>
-            <a:pPr algn="l">
-              <a:lnSpc>
-                <a:spcPts val="5160"/>
-              </a:lnSpc>
-            </a:pPr>
-            <a:r>
-              <a:rPr lang="en-US" sz="6000" spc="-60" b="true">
-                <a:solidFill>
-                  <a:srgbClr val="FFFFFF"/>
-                </a:solidFill>
-                <a:latin typeface="Roboto Condensed Bold"/>
-                <a:ea typeface="Roboto Condensed Bold"/>
-                <a:cs typeface="Roboto Condensed Bold"/>
-                <a:sym typeface="Roboto Condensed Bold"/>
-              </a:rPr>
-              <a:t>Contact Person</a:t>
-            </a:r>
-          </a:p>
+          <a:p/>
         </p:txBody>
       </p:sp>
       <p:sp>
@@ -5749,25 +5527,7 @@
             <a:spAutoFit/>
           </a:bodyPr>
           <a:lstStyle/>
-          <a:p>
-            <a:pPr algn="l">
-              <a:lnSpc>
-                <a:spcPts val="2800"/>
-              </a:lnSpc>
-            </a:pPr>
-            <a:r>
-              <a:rPr lang="en-US" sz="2000">
-                <a:solidFill>
-                  <a:srgbClr val="FFFFFF"/>
-                </a:solidFill>
-                <a:latin typeface="Roboto Condensed"/>
-                <a:ea typeface="Roboto Condensed"/>
-                <a:cs typeface="Roboto Condensed"/>
-                <a:sym typeface="Roboto Condensed"/>
-              </a:rPr>
-              <a:t>Clicking on the “Send us an email” button takes you right to the contact form.</a:t>
-            </a:r>
-          </a:p>
+          <a:p/>
         </p:txBody>
       </p:sp>
       <p:sp>
@@ -5790,37 +5550,7 @@
             <a:spAutoFit/>
           </a:bodyPr>
           <a:lstStyle/>
-          <a:p>
-            <a:pPr algn="l">
-              <a:lnSpc>
-                <a:spcPts val="4200"/>
-              </a:lnSpc>
-            </a:pPr>
-            <a:r>
-              <a:rPr lang="en-US" b="true" sz="3000">
-                <a:solidFill>
-                  <a:srgbClr val="FFFFFF"/>
-                </a:solidFill>
-                <a:latin typeface="Roboto Condensed Bold"/>
-                <a:ea typeface="Roboto Condensed Bold"/>
-                <a:cs typeface="Roboto Condensed Bold"/>
-                <a:sym typeface="Roboto Condensed Bold"/>
-              </a:rPr>
-              <a:t>SEND</a:t>
-            </a:r>
-            <a:r>
-              <a:rPr lang="en-US" b="true" sz="3000">
-                <a:solidFill>
-                  <a:srgbClr val="FFFFFF"/>
-                </a:solidFill>
-                <a:latin typeface="Roboto Condensed Bold"/>
-                <a:ea typeface="Roboto Condensed Bold"/>
-                <a:cs typeface="Roboto Condensed Bold"/>
-                <a:sym typeface="Roboto Condensed Bold"/>
-              </a:rPr>
-              <a:t> US</a:t>
-            </a:r>
-          </a:p>
+          <a:p/>
         </p:txBody>
       </p:sp>
       <p:sp>
@@ -5843,25 +5573,7 @@
             <a:spAutoFit/>
           </a:bodyPr>
           <a:lstStyle/>
-          <a:p>
-            <a:pPr algn="l">
-              <a:lnSpc>
-                <a:spcPts val="3920"/>
-              </a:lnSpc>
-            </a:pPr>
-            <a:r>
-              <a:rPr lang="en-US" sz="2800">
-                <a:solidFill>
-                  <a:srgbClr val="FFFFFF"/>
-                </a:solidFill>
-                <a:latin typeface="Roboto Condensed"/>
-                <a:ea typeface="Roboto Condensed"/>
-                <a:cs typeface="Roboto Condensed"/>
-                <a:sym typeface="Roboto Condensed"/>
-              </a:rPr>
-              <a:t>+123-456-7890</a:t>
-            </a:r>
-          </a:p>
+          <a:p/>
         </p:txBody>
       </p:sp>
       <p:sp>
@@ -5884,25 +5596,7 @@
             <a:spAutoFit/>
           </a:bodyPr>
           <a:lstStyle/>
-          <a:p>
-            <a:pPr algn="l">
-              <a:lnSpc>
-                <a:spcPts val="3920"/>
-              </a:lnSpc>
-            </a:pPr>
-            <a:r>
-              <a:rPr lang="en-US" sz="2800">
-                <a:solidFill>
-                  <a:srgbClr val="FFFFFF"/>
-                </a:solidFill>
-                <a:latin typeface="Roboto Condensed"/>
-                <a:ea typeface="Roboto Condensed"/>
-                <a:cs typeface="Roboto Condensed"/>
-                <a:sym typeface="Roboto Condensed"/>
-              </a:rPr>
-              <a:t>hello@reallygreatsite.com</a:t>
-            </a:r>
-          </a:p>
+          <a:p/>
         </p:txBody>
       </p:sp>
       <p:sp>
@@ -5928,6 +5622,10 @@
             <a:tailEnd type="none" len="sm" w="sm"/>
           </a:ln>
         </p:spPr>
+        <p:txBody>
+          <a:bodyPr/>
+          <a:p/>
+        </p:txBody>
       </p:sp>
       <p:sp>
         <p:nvSpPr>
@@ -5952,6 +5650,10 @@
             <a:tailEnd type="none" len="sm" w="sm"/>
           </a:ln>
         </p:spPr>
+        <p:txBody>
+          <a:bodyPr/>
+          <a:p/>
+        </p:txBody>
       </p:sp>
     </p:spTree>
   </p:cSld>

</xml_diff>